<commit_message>
reworked some templates, tidy, enhance, simplify
</commit_message>
<xml_diff>
--- a/tests/02_basetest/pptx-basic/internal_structures/placeholders.pptx
+++ b/tests/02_basetest/pptx-basic/internal_structures/placeholders.pptx
@@ -2252,7 +2252,7 @@
           <a:effectLst/>
           <a:latin typeface="+mj-lt"/>
           <a:ea typeface="+mj-ea"/>
-          <a:cs typeface="3ds Condensed"/>
+          <a:cs typeface="Scriptum Condensed"/>
         </a:defRPr>
       </a:lvl1pPr>
     </p:titleStyle>
@@ -2276,7 +2276,7 @@
           </a:solidFill>
           <a:latin typeface="+mn-lt"/>
           <a:ea typeface="+mn-ea"/>
-          <a:cs typeface="3ds Light"/>
+          <a:cs typeface="Scriptum Light"/>
         </a:defRPr>
       </a:lvl1pPr>
       <a:lvl2pPr marL="400050" marR="0" indent="-176213" algn="l" defTabSz="879152" rtl="0" eaLnBrk="1" fontAlgn="auto" latinLnBrk="0" hangingPunct="1">
@@ -2302,7 +2302,7 @@
           </a:solidFill>
           <a:latin typeface="+mn-lt"/>
           <a:ea typeface="+mn-ea"/>
-          <a:cs typeface="3ds Light"/>
+          <a:cs typeface="Scriptum Light"/>
         </a:defRPr>
       </a:lvl2pPr>
       <a:lvl3pPr marL="628650" marR="0" indent="-158750" algn="l" defTabSz="879152" rtl="0" eaLnBrk="1" fontAlgn="auto" latinLnBrk="0" hangingPunct="1">
@@ -2328,7 +2328,7 @@
           </a:solidFill>
           <a:latin typeface="+mn-lt"/>
           <a:ea typeface="+mn-ea"/>
-          <a:cs typeface="3ds Light"/>
+          <a:cs typeface="Scriptum Light"/>
         </a:defRPr>
       </a:lvl3pPr>
       <a:lvl4pPr marL="857250" indent="-179388" algn="l" defTabSz="879152" rtl="0" eaLnBrk="1" latinLnBrk="0" hangingPunct="1">
@@ -2350,7 +2350,7 @@
           </a:solidFill>
           <a:latin typeface="+mn-lt"/>
           <a:ea typeface="+mn-ea"/>
-          <a:cs typeface="3ds Light"/>
+          <a:cs typeface="Scriptum Light"/>
         </a:defRPr>
       </a:lvl4pPr>
       <a:lvl5pPr marL="914400" indent="0" algn="l" defTabSz="1028700" rtl="0" eaLnBrk="1" latinLnBrk="0" hangingPunct="1">
@@ -2368,7 +2368,7 @@
           </a:solidFill>
           <a:latin typeface="+mn-lt"/>
           <a:ea typeface="+mn-ea"/>
-          <a:cs typeface="3ds Light"/>
+          <a:cs typeface="Scriptum Light"/>
         </a:defRPr>
       </a:lvl5pPr>
       <a:lvl6pPr marL="2417668" indent="-219788" algn="l" defTabSz="879152" rtl="0" eaLnBrk="1" latinLnBrk="0" hangingPunct="1">
@@ -2837,7 +2837,7 @@
 <file path=ppt/theme/theme1.xml><?xml version="1.0" encoding="utf-8"?>
 <a:theme xmlns:a="http://schemas.openxmlformats.org/drawingml/2006/main" name="Customer">
   <a:themeElements>
-    <a:clrScheme name="3DS">
+    <a:clrScheme name="Scriptum">
       <a:dk1>
         <a:srgbClr val="005386"/>
       </a:dk1>
@@ -2875,7 +2875,7 @@
         <a:srgbClr val="800080"/>
       </a:folHlink>
     </a:clrScheme>
-    <a:fontScheme name="3DS PPT template">
+    <a:fontScheme name="Scriptum PPT template">
       <a:majorFont>
         <a:latin typeface="Arial Narrow"/>
         <a:ea typeface=""/>
@@ -3097,7 +3097,7 @@
   <a:extraClrSchemeLst/>
   <a:extLst>
     <a:ext uri="{05A4C25C-085E-4340-85A3-A5531E510DB2}">
-      <thm15:themeFamily xmlns:thm15="http://schemas.microsoft.com/office/thememl/2012/main" name="3DS_PPTX_Corp + Brand_Template_06_2015.pptx" id="{F2600C52-DB9A-4C10-AE98-F52812B72B4A}" vid="{D11FAF20-BC75-4E22-9A83-6DE1A8E85A29}"/>
+      <thm15:themeFamily xmlns:thm15="http://schemas.microsoft.com/office/thememl/2012/main" name="Scriptum_PPTX_Template.pptx" id="{F2600C52-DB9A-4C10-AE98-F52812B72B4A}" vid="{D11FAF20-BC75-4E22-9A83-6DE1A8E85A29}"/>
     </a:ext>
   </a:extLst>
 </a:theme>

</xml_diff>